<commit_message>
Update KAILA Founder Presentation materials and financial model
- Revised content in multiple presentation files to reflect updated product descriptions and financial projections.
- Adjusted funding scenarios and financial model to align with lean pilot approach and revised budget estimates.
- Enhanced clarity on market assumptions and pilot execution strategies in investor package documents.
- Updated startup guide to streamline the initial pilot process and emphasize the importance of validation before software development.
</commit_message>
<xml_diff>
--- a/KAILA_Founder_Grade_Package/KAILA Founder Presentation/KAILA Founder-Grade Package Presentation.pptx
+++ b/KAILA_Founder_Grade_Package/KAILA Founder Presentation/KAILA Founder-Grade Package Presentation.pptx
@@ -4708,13 +4708,6 @@
                     <a:bodyPr/>
                     <a:lstStyle/>
                     <a:p>
-                      <a:pPr>
-                        <a:defRPr sz="1000">
-                          <a:solidFill>
-                            <a:srgbClr val="122A31"/>
-                          </a:solidFill>
-                        </a:defRPr>
-                      </a:pPr>
                       <a:r>
                         <a:t>Appliance repair</a:t>
                       </a:r>
@@ -4727,13 +4720,6 @@
                     <a:bodyPr/>
                     <a:lstStyle/>
                     <a:p>
-                      <a:pPr>
-                        <a:defRPr sz="1000">
-                          <a:solidFill>
-                            <a:srgbClr val="122A31"/>
-                          </a:solidFill>
-                        </a:defRPr>
-                      </a:pPr>
                       <a:r>
                         <a:t>Washing machines, refrigerators, aircon, fans, rice cookers, small appliances.</a:t>
                       </a:r>
@@ -4748,13 +4734,6 @@
                     <a:bodyPr/>
                     <a:lstStyle/>
                     <a:p>
-                      <a:pPr>
-                        <a:defRPr sz="1000">
-                          <a:solidFill>
-                            <a:srgbClr val="122A31"/>
-                          </a:solidFill>
-                        </a:defRPr>
-                      </a:pPr>
                       <a:r>
                         <a:t>Plumbing</a:t>
                       </a:r>
@@ -4767,13 +4746,6 @@
                     <a:bodyPr/>
                     <a:lstStyle/>
                     <a:p>
-                      <a:pPr>
-                        <a:defRPr sz="1000">
-                          <a:solidFill>
-                            <a:srgbClr val="122A31"/>
-                          </a:solidFill>
-                        </a:defRPr>
-                      </a:pPr>
                       <a:r>
                         <a:t>Leaks, clogged drains, faucet replacement, water lines, toilet repair.</a:t>
                       </a:r>
@@ -4788,13 +4760,6 @@
                     <a:bodyPr/>
                     <a:lstStyle/>
                     <a:p>
-                      <a:pPr>
-                        <a:defRPr sz="1000">
-                          <a:solidFill>
-                            <a:srgbClr val="122A31"/>
-                          </a:solidFill>
-                        </a:defRPr>
-                      </a:pPr>
                       <a:r>
                         <a:t>Electrical</a:t>
                       </a:r>
@@ -4807,13 +4772,6 @@
                     <a:bodyPr/>
                     <a:lstStyle/>
                     <a:p>
-                      <a:pPr>
-                        <a:defRPr sz="1000">
-                          <a:solidFill>
-                            <a:srgbClr val="122A31"/>
-                          </a:solidFill>
-                        </a:defRPr>
-                      </a:pPr>
                       <a:r>
                         <a:t>Lights, outlets, breakers, wiring assessment, installation, troubleshooting.</a:t>
                       </a:r>
@@ -4828,13 +4786,6 @@
                     <a:bodyPr/>
                     <a:lstStyle/>
                     <a:p>
-                      <a:pPr>
-                        <a:defRPr sz="1000">
-                          <a:solidFill>
-                            <a:srgbClr val="122A31"/>
-                          </a:solidFill>
-                        </a:defRPr>
-                      </a:pPr>
                       <a:r>
                         <a:t>Computer repair</a:t>
                       </a:r>
@@ -4847,13 +4798,6 @@
                     <a:bodyPr/>
                     <a:lstStyle/>
                     <a:p>
-                      <a:pPr>
-                        <a:defRPr sz="1000">
-                          <a:solidFill>
-                            <a:srgbClr val="122A31"/>
-                          </a:solidFill>
-                        </a:defRPr>
-                      </a:pPr>
                       <a:r>
                         <a:t>Formatting, virus removal, slow PC optimization, basic hardware replacement.</a:t>
                       </a:r>
@@ -4868,15 +4812,8 @@
                     <a:bodyPr/>
                     <a:lstStyle/>
                     <a:p>
-                      <a:pPr>
-                        <a:defRPr sz="1000">
-                          <a:solidFill>
-                            <a:srgbClr val="122A31"/>
-                          </a:solidFill>
-                        </a:defRPr>
-                      </a:pPr>
-                      <a:r>
-                        <a:t>Mechanical</a:t>
+                      <a:r>
+                        <a:t>Cellphone repair</a:t>
                       </a:r>
                     </a:p>
                   </a:txBody>
@@ -4887,15 +4824,8 @@
                     <a:bodyPr/>
                     <a:lstStyle/>
                     <a:p>
-                      <a:pPr>
-                        <a:defRPr sz="1000">
-                          <a:solidFill>
-                            <a:srgbClr val="122A31"/>
-                          </a:solidFill>
-                        </a:defRPr>
-                      </a:pPr>
-                      <a:r>
-                        <a:t>Motorcycles, small engines, basic vehicle concerns.</a:t>
+                      <a:r>
+                        <a:t>Screen, battery, charging port, speaker, camera, and basic software issues.</a:t>
                       </a:r>
                     </a:p>
                   </a:txBody>
@@ -4908,15 +4838,8 @@
                     <a:bodyPr/>
                     <a:lstStyle/>
                     <a:p>
-                      <a:pPr>
-                        <a:defRPr sz="1000">
-                          <a:solidFill>
-                            <a:srgbClr val="122A31"/>
-                          </a:solidFill>
-                        </a:defRPr>
-                      </a:pPr>
-                      <a:r>
-                        <a:t>Home maintenance</a:t>
+                      <a:r>
+                        <a:t>Mechanical</a:t>
                       </a:r>
                     </a:p>
                   </a:txBody>
@@ -4927,15 +4850,8 @@
                     <a:bodyPr/>
                     <a:lstStyle/>
                     <a:p>
-                      <a:pPr>
-                        <a:defRPr sz="1000">
-                          <a:solidFill>
-                            <a:srgbClr val="122A31"/>
-                          </a:solidFill>
-                        </a:defRPr>
-                      </a:pPr>
-                      <a:r>
-                        <a:t>Carpentry, welding, painting, installation, cleaning, odd jobs.</a:t>
+                      <a:r>
+                        <a:t>Motorcycles, small engines, basic vehicle concerns.</a:t>
                       </a:r>
                     </a:p>
                   </a:txBody>
@@ -4948,13 +4864,32 @@
                     <a:bodyPr/>
                     <a:lstStyle/>
                     <a:p>
-                      <a:pPr>
-                        <a:defRPr sz="1000">
-                          <a:solidFill>
-                            <a:srgbClr val="122A31"/>
-                          </a:solidFill>
-                        </a:defRPr>
-                      </a:pPr>
+                      <a:r>
+                        <a:t>Home maintenance</a:t>
+                      </a:r>
+                    </a:p>
+                  </a:txBody>
+                  <a:tcPr/>
+                </a:tc>
+                <a:tc>
+                  <a:txBody>
+                    <a:bodyPr/>
+                    <a:lstStyle/>
+                    <a:p>
+                      <a:r>
+                        <a:t>Carpentry, welding, painting, installation, cleaning, odd jobs.</a:t>
+                      </a:r>
+                    </a:p>
+                  </a:txBody>
+                  <a:tcPr/>
+                </a:tc>
+              </a:tr>
+              <a:tr h="560070">
+                <a:tc>
+                  <a:txBody>
+                    <a:bodyPr/>
+                    <a:lstStyle/>
+                    <a:p>
                       <a:r>
                         <a:t>Digital services</a:t>
                       </a:r>
@@ -4967,13 +4902,6 @@
                     <a:bodyPr/>
                     <a:lstStyle/>
                     <a:p>
-                      <a:pPr>
-                        <a:defRPr sz="1000">
-                          <a:solidFill>
-                            <a:srgbClr val="122A31"/>
-                          </a:solidFill>
-                        </a:defRPr>
-                      </a:pPr>
                       <a:r>
                         <a:t>Graphic design, layout, tarpaulin design, basic digital work.</a:t>
                       </a:r>
@@ -10142,7 +10070,7 @@
                         </a:defRPr>
                       </a:pPr>
                       <a:r>
-                        <a:t>Run a manual version with Facebook, Google Forms, spreadsheet, and Messenger for 30 to 45 days.</a:t>
+                        <a:t>Run the browser MVP/native app plus Facebook concierge posting and Messenger follow-up for 30 to 45 days.</a:t>
                       </a:r>
                     </a:p>
                   </a:txBody>
@@ -13081,91 +13009,36 @@
             </a:r>
           </a:p>
           <a:p>
-            <a:pPr>
-              <a:spcAft>
-                <a:spcPts val="700"/>
-              </a:spcAft>
-              <a:defRPr sz="1700">
-                <a:solidFill>
-                  <a:srgbClr val="122A31"/>
-                </a:solidFill>
-              </a:defRPr>
-            </a:pPr>
             <a:r>
               <a:t>Electricians and plumbers who accept household jobs.</a:t>
             </a:r>
           </a:p>
           <a:p>
-            <a:pPr>
-              <a:spcAft>
-                <a:spcPts val="700"/>
-              </a:spcAft>
-              <a:defRPr sz="1700">
-                <a:solidFill>
-                  <a:srgbClr val="122A31"/>
-                </a:solidFill>
-              </a:defRPr>
-            </a:pPr>
             <a:r>
               <a:t>Motorcycle mechanics and small engine repair workers.</a:t>
             </a:r>
           </a:p>
           <a:p>
-            <a:pPr>
-              <a:spcAft>
-                <a:spcPts val="700"/>
-              </a:spcAft>
-              <a:defRPr sz="1700">
-                <a:solidFill>
-                  <a:srgbClr val="122A31"/>
-                </a:solidFill>
-              </a:defRPr>
-            </a:pPr>
             <a:r>
               <a:t>Computer repair technicians and software troubleshooters.</a:t>
             </a:r>
           </a:p>
           <a:p>
-            <a:pPr>
-              <a:spcAft>
-                <a:spcPts val="700"/>
-              </a:spcAft>
-              <a:defRPr sz="1700">
-                <a:solidFill>
-                  <a:srgbClr val="122A31"/>
-                </a:solidFill>
-              </a:defRPr>
-            </a:pPr>
+            <a:r>
+              <a:t>Cellphone repair technicians and small phone repair stalls.</a:t>
+            </a:r>
+          </a:p>
+          <a:p>
             <a:r>
               <a:t>Carpenters, welders, painters, and general maintenance workers.</a:t>
             </a:r>
           </a:p>
           <a:p>
-            <a:pPr>
-              <a:spcAft>
-                <a:spcPts val="700"/>
-              </a:spcAft>
-              <a:defRPr sz="1700">
-                <a:solidFill>
-                  <a:srgbClr val="122A31"/>
-                </a:solidFill>
-              </a:defRPr>
-            </a:pPr>
             <a:r>
               <a:t>Graphic designers, layout artists, tarpaulin designers, and digital freelancers.</a:t>
             </a:r>
           </a:p>
           <a:p>
-            <a:pPr>
-              <a:spcAft>
-                <a:spcPts val="700"/>
-              </a:spcAft>
-              <a:defRPr sz="1700">
-                <a:solidFill>
-                  <a:srgbClr val="122A31"/>
-                </a:solidFill>
-              </a:defRPr>
-            </a:pPr>
             <a:r>
               <a:t>Cleaning, gardening, errands, hauling, manpower providers, and small service shops.</a:t>
             </a:r>
@@ -15921,13 +15794,6 @@
                     <a:bodyPr/>
                     <a:lstStyle/>
                     <a:p>
-                      <a:pPr>
-                        <a:defRPr sz="900">
-                          <a:solidFill>
-                            <a:srgbClr val="122A31"/>
-                          </a:solidFill>
-                        </a:defRPr>
-                      </a:pPr>
                       <a:r>
                         <a:t>Appliance repair</a:t>
                       </a:r>
@@ -15940,15 +15806,8 @@
                     <a:bodyPr/>
                     <a:lstStyle/>
                     <a:p>
-                      <a:pPr>
-                        <a:defRPr sz="900">
-                          <a:solidFill>
-                            <a:srgbClr val="122A31"/>
-                          </a:solidFill>
-                        </a:defRPr>
-                      </a:pPr>
-                      <a:r>
-                        <a:t>8</a:t>
+                      <a:r>
+                        <a:t>7</a:t>
                       </a:r>
                     </a:p>
                   </a:txBody>
@@ -15959,15 +15818,8 @@
                     <a:bodyPr/>
                     <a:lstStyle/>
                     <a:p>
-                      <a:pPr>
-                        <a:defRPr sz="900">
-                          <a:solidFill>
-                            <a:srgbClr val="122A31"/>
-                          </a:solidFill>
-                        </a:defRPr>
-                      </a:pPr>
-                      <a:r>
-                        <a:t>15</a:t>
+                      <a:r>
+                        <a:t>12</a:t>
                       </a:r>
                     </a:p>
                   </a:txBody>
@@ -15978,13 +15830,6 @@
                     <a:bodyPr/>
                     <a:lstStyle/>
                     <a:p>
-                      <a:pPr>
-                        <a:defRPr sz="900">
-                          <a:solidFill>
-                            <a:srgbClr val="122A31"/>
-                          </a:solidFill>
-                        </a:defRPr>
-                      </a:pPr>
                       <a:r>
                         <a:t>High household demand and urgent repair needs.</a:t>
                       </a:r>
@@ -15999,13 +15844,6 @@
                     <a:bodyPr/>
                     <a:lstStyle/>
                     <a:p>
-                      <a:pPr>
-                        <a:defRPr sz="900">
-                          <a:solidFill>
-                            <a:srgbClr val="122A31"/>
-                          </a:solidFill>
-                        </a:defRPr>
-                      </a:pPr>
                       <a:r>
                         <a:t>Plumbing</a:t>
                       </a:r>
@@ -16018,13 +15856,6 @@
                     <a:bodyPr/>
                     <a:lstStyle/>
                     <a:p>
-                      <a:pPr>
-                        <a:defRPr sz="900">
-                          <a:solidFill>
-                            <a:srgbClr val="122A31"/>
-                          </a:solidFill>
-                        </a:defRPr>
-                      </a:pPr>
                       <a:r>
                         <a:t>6</a:t>
                       </a:r>
@@ -16037,15 +15868,8 @@
                     <a:bodyPr/>
                     <a:lstStyle/>
                     <a:p>
-                      <a:pPr>
-                        <a:defRPr sz="900">
-                          <a:solidFill>
-                            <a:srgbClr val="122A31"/>
-                          </a:solidFill>
-                        </a:defRPr>
-                      </a:pPr>
-                      <a:r>
-                        <a:t>12</a:t>
+                      <a:r>
+                        <a:t>10</a:t>
                       </a:r>
                     </a:p>
                   </a:txBody>
@@ -16056,13 +15880,6 @@
                     <a:bodyPr/>
                     <a:lstStyle/>
                     <a:p>
-                      <a:pPr>
-                        <a:defRPr sz="900">
-                          <a:solidFill>
-                            <a:srgbClr val="122A31"/>
-                          </a:solidFill>
-                        </a:defRPr>
-                      </a:pPr>
                       <a:r>
                         <a:t>Leak and clog problems require fast response.</a:t>
                       </a:r>
@@ -16077,13 +15894,6 @@
                     <a:bodyPr/>
                     <a:lstStyle/>
                     <a:p>
-                      <a:pPr>
-                        <a:defRPr sz="900">
-                          <a:solidFill>
-                            <a:srgbClr val="122A31"/>
-                          </a:solidFill>
-                        </a:defRPr>
-                      </a:pPr>
                       <a:r>
                         <a:t>Electrical</a:t>
                       </a:r>
@@ -16096,13 +15906,6 @@
                     <a:bodyPr/>
                     <a:lstStyle/>
                     <a:p>
-                      <a:pPr>
-                        <a:defRPr sz="900">
-                          <a:solidFill>
-                            <a:srgbClr val="122A31"/>
-                          </a:solidFill>
-                        </a:defRPr>
-                      </a:pPr>
                       <a:r>
                         <a:t>6</a:t>
                       </a:r>
@@ -16115,15 +15918,8 @@
                     <a:bodyPr/>
                     <a:lstStyle/>
                     <a:p>
-                      <a:pPr>
-                        <a:defRPr sz="900">
-                          <a:solidFill>
-                            <a:srgbClr val="122A31"/>
-                          </a:solidFill>
-                        </a:defRPr>
-                      </a:pPr>
-                      <a:r>
-                        <a:t>12</a:t>
+                      <a:r>
+                        <a:t>10</a:t>
                       </a:r>
                     </a:p>
                   </a:txBody>
@@ -16134,13 +15930,6 @@
                     <a:bodyPr/>
                     <a:lstStyle/>
                     <a:p>
-                      <a:pPr>
-                        <a:defRPr sz="900">
-                          <a:solidFill>
-                            <a:srgbClr val="122A31"/>
-                          </a:solidFill>
-                        </a:defRPr>
-                      </a:pPr>
                       <a:r>
                         <a:t>Safety-sensitive and common household need.</a:t>
                       </a:r>
@@ -16155,13 +15944,6 @@
                     <a:bodyPr/>
                     <a:lstStyle/>
                     <a:p>
-                      <a:pPr>
-                        <a:defRPr sz="900">
-                          <a:solidFill>
-                            <a:srgbClr val="122A31"/>
-                          </a:solidFill>
-                        </a:defRPr>
-                      </a:pPr>
                       <a:r>
                         <a:t>Computer repair</a:t>
                       </a:r>
@@ -16174,13 +15956,6 @@
                     <a:bodyPr/>
                     <a:lstStyle/>
                     <a:p>
-                      <a:pPr>
-                        <a:defRPr sz="900">
-                          <a:solidFill>
-                            <a:srgbClr val="122A31"/>
-                          </a:solidFill>
-                        </a:defRPr>
-                      </a:pPr>
                       <a:r>
                         <a:t>5</a:t>
                       </a:r>
@@ -16193,15 +15968,8 @@
                     <a:bodyPr/>
                     <a:lstStyle/>
                     <a:p>
-                      <a:pPr>
-                        <a:defRPr sz="900">
-                          <a:solidFill>
-                            <a:srgbClr val="122A31"/>
-                          </a:solidFill>
-                        </a:defRPr>
-                      </a:pPr>
-                      <a:r>
-                        <a:t>10</a:t>
+                      <a:r>
+                        <a:t>8</a:t>
                       </a:r>
                     </a:p>
                   </a:txBody>
@@ -16212,13 +15980,6 @@
                     <a:bodyPr/>
                     <a:lstStyle/>
                     <a:p>
-                      <a:pPr>
-                        <a:defRPr sz="900">
-                          <a:solidFill>
-                            <a:srgbClr val="122A31"/>
-                          </a:solidFill>
-                        </a:defRPr>
-                      </a:pPr>
                       <a:r>
                         <a:t>Strong fit with students, offices, and households.</a:t>
                       </a:r>
@@ -16233,15 +15994,8 @@
                     <a:bodyPr/>
                     <a:lstStyle/>
                     <a:p>
-                      <a:pPr>
-                        <a:defRPr sz="900">
-                          <a:solidFill>
-                            <a:srgbClr val="122A31"/>
-                          </a:solidFill>
-                        </a:defRPr>
-                      </a:pPr>
-                      <a:r>
-                        <a:t>Mechanical / motorcycle</a:t>
+                      <a:r>
+                        <a:t>Cellphone repair</a:t>
                       </a:r>
                     </a:p>
                   </a:txBody>
@@ -16252,15 +16006,8 @@
                     <a:bodyPr/>
                     <a:lstStyle/>
                     <a:p>
-                      <a:pPr>
-                        <a:defRPr sz="900">
-                          <a:solidFill>
-                            <a:srgbClr val="122A31"/>
-                          </a:solidFill>
-                        </a:defRPr>
-                      </a:pPr>
-                      <a:r>
-                        <a:t>5</a:t>
+                      <a:r>
+                        <a:t>6</a:t>
                       </a:r>
                     </a:p>
                   </a:txBody>
@@ -16271,13 +16018,6 @@
                     <a:bodyPr/>
                     <a:lstStyle/>
                     <a:p>
-                      <a:pPr>
-                        <a:defRPr sz="900">
-                          <a:solidFill>
-                            <a:srgbClr val="122A31"/>
-                          </a:solidFill>
-                        </a:defRPr>
-                      </a:pPr>
                       <a:r>
                         <a:t>10</a:t>
                       </a:r>
@@ -16290,15 +16030,8 @@
                     <a:bodyPr/>
                     <a:lstStyle/>
                     <a:p>
-                      <a:pPr>
-                        <a:defRPr sz="900">
-                          <a:solidFill>
-                            <a:srgbClr val="122A31"/>
-                          </a:solidFill>
-                        </a:defRPr>
-                      </a:pPr>
-                      <a:r>
-                        <a:t>Common in local communities.</a:t>
+                      <a:r>
+                        <a:t>Frequent phone screen, battery, charging, and software issues.</a:t>
                       </a:r>
                     </a:p>
                   </a:txBody>
@@ -16311,15 +16044,8 @@
                     <a:bodyPr/>
                     <a:lstStyle/>
                     <a:p>
-                      <a:pPr>
-                        <a:defRPr sz="900">
-                          <a:solidFill>
-                            <a:srgbClr val="122A31"/>
-                          </a:solidFill>
-                        </a:defRPr>
-                      </a:pPr>
-                      <a:r>
-                        <a:t>Carpentry / home maintenance</a:t>
+                      <a:r>
+                        <a:t>Mechanical / motorcycle</a:t>
                       </a:r>
                     </a:p>
                   </a:txBody>
@@ -16330,13 +16056,6 @@
                     <a:bodyPr/>
                     <a:lstStyle/>
                     <a:p>
-                      <a:pPr>
-                        <a:defRPr sz="900">
-                          <a:solidFill>
-                            <a:srgbClr val="122A31"/>
-                          </a:solidFill>
-                        </a:defRPr>
-                      </a:pPr>
                       <a:r>
                         <a:t>5</a:t>
                       </a:r>
@@ -16349,15 +16068,8 @@
                     <a:bodyPr/>
                     <a:lstStyle/>
                     <a:p>
-                      <a:pPr>
-                        <a:defRPr sz="900">
-                          <a:solidFill>
-                            <a:srgbClr val="122A31"/>
-                          </a:solidFill>
-                        </a:defRPr>
-                      </a:pPr>
-                      <a:r>
-                        <a:t>10</a:t>
+                      <a:r>
+                        <a:t>8</a:t>
                       </a:r>
                     </a:p>
                   </a:txBody>
@@ -16368,15 +16080,8 @@
                     <a:bodyPr/>
                     <a:lstStyle/>
                     <a:p>
-                      <a:pPr>
-                        <a:defRPr sz="900">
-                          <a:solidFill>
-                            <a:srgbClr val="122A31"/>
-                          </a:solidFill>
-                        </a:defRPr>
-                      </a:pPr>
-                      <a:r>
-                        <a:t>Frequent small repair and improvement jobs.</a:t>
+                      <a:r>
+                        <a:t>Common in local communities.</a:t>
                       </a:r>
                     </a:p>
                   </a:txBody>
@@ -16389,15 +16094,8 @@
                     <a:bodyPr/>
                     <a:lstStyle/>
                     <a:p>
-                      <a:pPr>
-                        <a:defRPr sz="900">
-                          <a:solidFill>
-                            <a:srgbClr val="122A31"/>
-                          </a:solidFill>
-                        </a:defRPr>
-                      </a:pPr>
-                      <a:r>
-                        <a:t>Graphic / digital services</a:t>
+                      <a:r>
+                        <a:t>Carpentry / home maintenance</a:t>
                       </a:r>
                     </a:p>
                   </a:txBody>
@@ -16408,13 +16106,6 @@
                     <a:bodyPr/>
                     <a:lstStyle/>
                     <a:p>
-                      <a:pPr>
-                        <a:defRPr sz="900">
-                          <a:solidFill>
-                            <a:srgbClr val="122A31"/>
-                          </a:solidFill>
-                        </a:defRPr>
-                      </a:pPr>
                       <a:r>
                         <a:t>5</a:t>
                       </a:r>
@@ -16427,15 +16118,8 @@
                     <a:bodyPr/>
                     <a:lstStyle/>
                     <a:p>
-                      <a:pPr>
-                        <a:defRPr sz="900">
-                          <a:solidFill>
-                            <a:srgbClr val="122A31"/>
-                          </a:solidFill>
-                        </a:defRPr>
-                      </a:pPr>
-                      <a:r>
-                        <a:t>10</a:t>
+                      <a:r>
+                        <a:t>8</a:t>
                       </a:r>
                     </a:p>
                   </a:txBody>
@@ -16446,15 +16130,8 @@
                     <a:bodyPr/>
                     <a:lstStyle/>
                     <a:p>
-                      <a:pPr>
-                        <a:defRPr sz="900">
-                          <a:solidFill>
-                            <a:srgbClr val="122A31"/>
-                          </a:solidFill>
-                        </a:defRPr>
-                      </a:pPr>
-                      <a:r>
-                        <a:t>Useful for local events, businesses, and students.</a:t>
+                      <a:r>
+                        <a:t>Frequent small repair and improvement jobs.</a:t>
                       </a:r>
                     </a:p>
                   </a:txBody>
@@ -16467,13 +16144,56 @@
                     <a:bodyPr/>
                     <a:lstStyle/>
                     <a:p>
-                      <a:pPr>
-                        <a:defRPr sz="900">
-                          <a:solidFill>
-                            <a:srgbClr val="122A31"/>
-                          </a:solidFill>
-                        </a:defRPr>
-                      </a:pPr>
+                      <a:r>
+                        <a:t>Graphic / digital services</a:t>
+                      </a:r>
+                    </a:p>
+                  </a:txBody>
+                  <a:tcPr/>
+                </a:tc>
+                <a:tc>
+                  <a:txBody>
+                    <a:bodyPr/>
+                    <a:lstStyle/>
+                    <a:p>
+                      <a:r>
+                        <a:t>4</a:t>
+                      </a:r>
+                    </a:p>
+                  </a:txBody>
+                  <a:tcPr/>
+                </a:tc>
+                <a:tc>
+                  <a:txBody>
+                    <a:bodyPr/>
+                    <a:lstStyle/>
+                    <a:p>
+                      <a:r>
+                        <a:t>7</a:t>
+                      </a:r>
+                    </a:p>
+                  </a:txBody>
+                  <a:tcPr/>
+                </a:tc>
+                <a:tc>
+                  <a:txBody>
+                    <a:bodyPr/>
+                    <a:lstStyle/>
+                    <a:p>
+                      <a:r>
+                        <a:t>Useful for local events, businesses, and students.</a:t>
+                      </a:r>
+                    </a:p>
+                  </a:txBody>
+                  <a:tcPr/>
+                </a:tc>
+              </a:tr>
+              <a:tr h="497840">
+                <a:tc>
+                  <a:txBody>
+                    <a:bodyPr/>
+                    <a:lstStyle/>
+                    <a:p>
                       <a:r>
                         <a:t>General odd jobs</a:t>
                       </a:r>
@@ -16486,15 +16206,8 @@
                     <a:bodyPr/>
                     <a:lstStyle/>
                     <a:p>
-                      <a:pPr>
-                        <a:defRPr sz="900">
-                          <a:solidFill>
-                            <a:srgbClr val="122A31"/>
-                          </a:solidFill>
-                        </a:defRPr>
-                      </a:pPr>
-                      <a:r>
-                        <a:t>10</a:t>
+                      <a:r>
+                        <a:t>6</a:t>
                       </a:r>
                     </a:p>
                   </a:txBody>
@@ -16505,15 +16218,8 @@
                     <a:bodyPr/>
                     <a:lstStyle/>
                     <a:p>
-                      <a:pPr>
-                        <a:defRPr sz="900">
-                          <a:solidFill>
-                            <a:srgbClr val="122A31"/>
-                          </a:solidFill>
-                        </a:defRPr>
-                      </a:pPr>
-                      <a:r>
-                        <a:t>20</a:t>
+                      <a:r>
+                        <a:t>12</a:t>
                       </a:r>
                     </a:p>
                   </a:txBody>
@@ -16524,13 +16230,6 @@
                     <a:bodyPr/>
                     <a:lstStyle/>
                     <a:p>
-                      <a:pPr>
-                        <a:defRPr sz="900">
-                          <a:solidFill>
-                            <a:srgbClr val="122A31"/>
-                          </a:solidFill>
-                        </a:defRPr>
-                      </a:pPr>
                       <a:r>
                         <a:t>Flexible supply for miscellaneous needs.</a:t>
                       </a:r>
@@ -19416,78 +19115,28 @@
             </a:r>
           </a:p>
           <a:p>
-            <a:pPr>
-              <a:spcAft>
-                <a:spcPts val="700"/>
-              </a:spcAft>
-              <a:defRPr sz="1700">
-                <a:solidFill>
-                  <a:srgbClr val="122A31"/>
-                </a:solidFill>
-              </a:defRPr>
-            </a:pPr>
             <a:r>
               <a:t>GPS live tracking.</a:t>
             </a:r>
           </a:p>
           <a:p>
-            <a:pPr>
-              <a:spcAft>
-                <a:spcPts val="700"/>
-              </a:spcAft>
-              <a:defRPr sz="1700">
-                <a:solidFill>
-                  <a:srgbClr val="122A31"/>
-                </a:solidFill>
-              </a:defRPr>
-            </a:pPr>
-            <a:r>
-              <a:t>Native mobile apps.</a:t>
-            </a:r>
-          </a:p>
-          <a:p>
-            <a:pPr>
-              <a:spcAft>
-                <a:spcPts val="700"/>
-              </a:spcAft>
-              <a:defRPr sz="1700">
-                <a:solidFill>
-                  <a:srgbClr val="122A31"/>
-                </a:solidFill>
-              </a:defRPr>
-            </a:pPr>
+            <a:r>
+              <a:t>Native app polish beyond the current wrapper.</a:t>
+            </a:r>
+          </a:p>
+          <a:p>
             <a:r>
               <a:t>Complex AI matching.</a:t>
             </a:r>
           </a:p>
           <a:p>
-            <a:pPr>
-              <a:spcAft>
-                <a:spcPts val="700"/>
-              </a:spcAft>
-              <a:defRPr sz="1700">
-                <a:solidFill>
-                  <a:srgbClr val="122A31"/>
-                </a:solidFill>
-              </a:defRPr>
-            </a:pPr>
             <a:r>
               <a:t>Large-scale marketplace automation.</a:t>
             </a:r>
           </a:p>
           <a:p>
-            <a:pPr>
-              <a:spcAft>
-                <a:spcPts val="700"/>
-              </a:spcAft>
-              <a:defRPr sz="1700">
-                <a:solidFill>
-                  <a:srgbClr val="122A31"/>
-                </a:solidFill>
-              </a:defRPr>
-            </a:pPr>
-            <a:r>
-              <a:t>These can be considered only after validation proves the core behavior.</a:t>
+            <a:r>
+              <a:t>Defer heavy automation and paid infrastructure until validation proves the core behavior.</a:t>
             </a:r>
           </a:p>
         </p:txBody>
@@ -20777,65 +20426,25 @@
               </a:defRPr>
             </a:pPr>
             <a:r>
-              <a:t>Business validation comes before full app development.</a:t>
-            </a:r>
-          </a:p>
-          <a:p>
-            <a:pPr>
-              <a:spcAft>
-                <a:spcPts val="700"/>
-              </a:spcAft>
-              <a:defRPr sz="1700">
-                <a:solidFill>
-                  <a:srgbClr val="122A31"/>
-                </a:solidFill>
-              </a:defRPr>
-            </a:pPr>
+              <a:t>Business validation continues through the live MVP and concierge pilot.</a:t>
+            </a:r>
+          </a:p>
+          <a:p>
             <a:r>
               <a:t>No founder should be treated as merely a helper if expected to carry core responsibility.</a:t>
             </a:r>
           </a:p>
           <a:p>
-            <a:pPr>
-              <a:spcAft>
-                <a:spcPts val="700"/>
-              </a:spcAft>
-              <a:defRPr sz="1700">
-                <a:solidFill>
-                  <a:srgbClr val="122A31"/>
-                </a:solidFill>
-              </a:defRPr>
-            </a:pPr>
             <a:r>
               <a:t>Ownership should reflect contribution, risk, time commitment, and long-term responsibility.</a:t>
             </a:r>
           </a:p>
           <a:p>
-            <a:pPr>
-              <a:spcAft>
-                <a:spcPts val="700"/>
-              </a:spcAft>
-              <a:defRPr sz="1700">
-                <a:solidFill>
-                  <a:srgbClr val="122A31"/>
-                </a:solidFill>
-              </a:defRPr>
-            </a:pPr>
             <a:r>
               <a:t>Important decisions should be documented.</a:t>
             </a:r>
           </a:p>
           <a:p>
-            <a:pPr>
-              <a:spcAft>
-                <a:spcPts val="700"/>
-              </a:spcAft>
-              <a:defRPr sz="1700">
-                <a:solidFill>
-                  <a:srgbClr val="122A31"/>
-                </a:solidFill>
-              </a:defRPr>
-            </a:pPr>
             <a:r>
               <a:t>The team should protect trust, fairness, and transparency from the beginning.</a:t>
             </a:r>
@@ -22468,7 +22077,7 @@
                         </a:defRPr>
                       </a:pPr>
                       <a:r>
-                        <a:t>Monthly fixed operating cost</a:t>
+                        <a:t>Monthly lean operating cost</a:t>
                       </a:r>
                     </a:p>
                   </a:txBody>
@@ -22487,7 +22096,7 @@
                         </a:defRPr>
                       </a:pPr>
                       <a:r>
-                        <a:t>PHP 20,000</a:t>
+                        <a:t>PHP 2,500</a:t>
                       </a:r>
                     </a:p>
                   </a:txBody>
@@ -23210,37 +22819,17 @@
               </a:defRPr>
             </a:pPr>
             <a:r>
-              <a:t>The field forms are designed for validation and early operations.</a:t>
-            </a:r>
-          </a:p>
-          <a:p>
-            <a:pPr>
-              <a:spcAft>
-                <a:spcPts val="700"/>
-              </a:spcAft>
-              <a:defRPr sz="1700">
-                <a:solidFill>
-                  <a:srgbClr val="122A31"/>
-                </a:solidFill>
-              </a:defRPr>
-            </a:pPr>
-            <a:r>
-              <a:t>They can be printed or copied into Google Forms and Google Sheets.</a:t>
-            </a:r>
-          </a:p>
-          <a:p>
-            <a:pPr>
-              <a:spcAft>
-                <a:spcPts val="700"/>
-              </a:spcAft>
-              <a:defRPr sz="1700">
-                <a:solidFill>
-                  <a:srgbClr val="122A31"/>
-                </a:solidFill>
-              </a:defRPr>
-            </a:pPr>
-            <a:r>
-              <a:t>The goal is to collect real client, provider, request, job, and meeting data before full development.</a:t>
+              <a:t>The survey and interview forms are built into the KAILA app for validation and early operations.</a:t>
+            </a:r>
+          </a:p>
+          <a:p>
+            <a:r>
+              <a:t>Printable or Google Form copies can remain as backup.</a:t>
+            </a:r>
+          </a:p>
+          <a:p>
+            <a:r>
+              <a:t>The goal is to collect real client, provider, request, job, and meeting data during the Facebook concierge pilot.</a:t>
             </a:r>
           </a:p>
         </p:txBody>
@@ -25688,7 +25277,7 @@
                         </a:defRPr>
                       </a:pPr>
                       <a:r>
-                        <a:t>Manual marketplace test using forms, spreadsheets, Facebook, and Messenger before full app build.</a:t>
+                        <a:t>Marketplace test using the existing app plus Facebook page posts, Messenger follow-up, and manual operations support.</a:t>
                       </a:r>
                     </a:p>
                   </a:txBody>

</xml_diff>